<commit_message>
Renumber pitch slides to match the actual 8-slide deck.
Drop leftover Product School Slide 5–11 labels so numbering aligns with cover through story.

Co-authored-by: Cursor <cursoragent@cursor.com>
</commit_message>
<xml_diff>
--- a/FinWise-Pitch.pptx
+++ b/FinWise-Pitch.pptx
@@ -3411,7 +3411,7 @@
                 </a:solidFill>
                 <a:latin typeface="Calibri"/>
               </a:rPr>
-              <a:t>SLIDE 5 · THE BET</a:t>
+              <a:t>SLIDE 2 · THE BET</a:t>
             </a:r>
           </a:p>
         </p:txBody>
@@ -3849,7 +3849,7 @@
                 </a:solidFill>
                 <a:latin typeface="Calibri"/>
               </a:rPr>
-              <a:t>SLIDE 6 · THE SOLUTION</a:t>
+              <a:t>SLIDE 3 · THE SOLUTION</a:t>
             </a:r>
           </a:p>
         </p:txBody>
@@ -4372,7 +4372,7 @@
                 </a:solidFill>
                 <a:latin typeface="Calibri"/>
               </a:rPr>
-              <a:t>SLIDE 7 · THE MECHANIC</a:t>
+              <a:t>SLIDE 4 · THE MECHANIC</a:t>
             </a:r>
           </a:p>
         </p:txBody>
@@ -4755,7 +4755,7 @@
                 </a:solidFill>
                 <a:latin typeface="Calibri"/>
               </a:rPr>
-              <a:t>SLIDE 8 · THE SIGNALS</a:t>
+              <a:t>SLIDE 5 · THE SIGNALS</a:t>
             </a:r>
           </a:p>
         </p:txBody>
@@ -5403,7 +5403,7 @@
                 </a:solidFill>
                 <a:latin typeface="Calibri"/>
               </a:rPr>
-              <a:t>SLIDE 9 · THE VALIDATION</a:t>
+              <a:t>SLIDE 6 · THE VALIDATION</a:t>
             </a:r>
           </a:p>
         </p:txBody>
@@ -6232,7 +6232,7 @@
                 </a:solidFill>
                 <a:latin typeface="Calibri"/>
               </a:rPr>
-              <a:t>SLIDE 10 · THE MODEL</a:t>
+              <a:t>SLIDE 7 · THE MODEL</a:t>
             </a:r>
           </a:p>
         </p:txBody>
@@ -7037,7 +7037,7 @@
                 </a:solidFill>
                 <a:latin typeface="Calibri"/>
               </a:rPr>
-              <a:t>SLIDE 11 · THE STORY</a:t>
+              <a:t>SLIDE 8 · THE STORY</a:t>
             </a:r>
           </a:p>
         </p:txBody>

</xml_diff>

<commit_message>
Restore Product School slide labels (5–11) on the pitch deck.
Revert sequential 2–8 renumbering so labels match the certification pitch template again.

Co-authored-by: Cursor <cursoragent@cursor.com>
</commit_message>
<xml_diff>
--- a/FinWise-Pitch.pptx
+++ b/FinWise-Pitch.pptx
@@ -3411,7 +3411,7 @@
                 </a:solidFill>
                 <a:latin typeface="Calibri"/>
               </a:rPr>
-              <a:t>SLIDE 2 · THE BET</a:t>
+              <a:t>SLIDE 5 · THE BET</a:t>
             </a:r>
           </a:p>
         </p:txBody>
@@ -3849,7 +3849,7 @@
                 </a:solidFill>
                 <a:latin typeface="Calibri"/>
               </a:rPr>
-              <a:t>SLIDE 3 · THE SOLUTION</a:t>
+              <a:t>SLIDE 6 · THE SOLUTION</a:t>
             </a:r>
           </a:p>
         </p:txBody>
@@ -4372,7 +4372,7 @@
                 </a:solidFill>
                 <a:latin typeface="Calibri"/>
               </a:rPr>
-              <a:t>SLIDE 4 · THE MECHANIC</a:t>
+              <a:t>SLIDE 7 · THE MECHANIC</a:t>
             </a:r>
           </a:p>
         </p:txBody>
@@ -4755,7 +4755,7 @@
                 </a:solidFill>
                 <a:latin typeface="Calibri"/>
               </a:rPr>
-              <a:t>SLIDE 5 · THE SIGNALS</a:t>
+              <a:t>SLIDE 8 · THE SIGNALS</a:t>
             </a:r>
           </a:p>
         </p:txBody>
@@ -5403,7 +5403,7 @@
                 </a:solidFill>
                 <a:latin typeface="Calibri"/>
               </a:rPr>
-              <a:t>SLIDE 6 · THE VALIDATION</a:t>
+              <a:t>SLIDE 9 · THE VALIDATION</a:t>
             </a:r>
           </a:p>
         </p:txBody>
@@ -6232,7 +6232,7 @@
                 </a:solidFill>
                 <a:latin typeface="Calibri"/>
               </a:rPr>
-              <a:t>SLIDE 7 · THE MODEL</a:t>
+              <a:t>SLIDE 10 · THE MODEL</a:t>
             </a:r>
           </a:p>
         </p:txBody>
@@ -7037,7 +7037,7 @@
                 </a:solidFill>
                 <a:latin typeface="Calibri"/>
               </a:rPr>
-              <a:t>SLIDE 8 · THE STORY</a:t>
+              <a:t>SLIDE 11 · THE STORY</a:t>
             </a:r>
           </a:p>
         </p:txBody>

</xml_diff>

<commit_message>
Fix pitch labels only: Bet is slide 2 through Story as slide 8.
All eight slides kept; only eyebrow/nav numbers updated to match deck order.

Co-authored-by: Cursor <cursoragent@cursor.com>
</commit_message>
<xml_diff>
--- a/FinWise-Pitch.pptx
+++ b/FinWise-Pitch.pptx
@@ -3411,7 +3411,7 @@
                 </a:solidFill>
                 <a:latin typeface="Calibri"/>
               </a:rPr>
-              <a:t>SLIDE 5 · THE BET</a:t>
+              <a:t>SLIDE 2 · THE BET</a:t>
             </a:r>
           </a:p>
         </p:txBody>
@@ -3849,7 +3849,7 @@
                 </a:solidFill>
                 <a:latin typeface="Calibri"/>
               </a:rPr>
-              <a:t>SLIDE 6 · THE SOLUTION</a:t>
+              <a:t>SLIDE 3 · THE SOLUTION</a:t>
             </a:r>
           </a:p>
         </p:txBody>
@@ -4372,7 +4372,7 @@
                 </a:solidFill>
                 <a:latin typeface="Calibri"/>
               </a:rPr>
-              <a:t>SLIDE 7 · THE MECHANIC</a:t>
+              <a:t>SLIDE 4 · THE MECHANIC</a:t>
             </a:r>
           </a:p>
         </p:txBody>
@@ -4755,7 +4755,7 @@
                 </a:solidFill>
                 <a:latin typeface="Calibri"/>
               </a:rPr>
-              <a:t>SLIDE 8 · THE SIGNALS</a:t>
+              <a:t>SLIDE 5 · THE SIGNALS</a:t>
             </a:r>
           </a:p>
         </p:txBody>
@@ -5403,7 +5403,7 @@
                 </a:solidFill>
                 <a:latin typeface="Calibri"/>
               </a:rPr>
-              <a:t>SLIDE 9 · THE VALIDATION</a:t>
+              <a:t>SLIDE 6 · THE VALIDATION</a:t>
             </a:r>
           </a:p>
         </p:txBody>
@@ -6232,7 +6232,7 @@
                 </a:solidFill>
                 <a:latin typeface="Calibri"/>
               </a:rPr>
-              <a:t>SLIDE 10 · THE MODEL</a:t>
+              <a:t>SLIDE 7 · THE MODEL</a:t>
             </a:r>
           </a:p>
         </p:txBody>
@@ -7037,7 +7037,7 @@
                 </a:solidFill>
                 <a:latin typeface="Calibri"/>
               </a:rPr>
-              <a:t>SLIDE 11 · THE STORY</a:t>
+              <a:t>SLIDE 8 · THE STORY</a:t>
             </a:r>
           </a:p>
         </p:txBody>

</xml_diff>